<commit_message>
Frontend- Show categories depending on status
</commit_message>
<xml_diff>
--- a/.lessons/56 Category, Subcategory and Child Category Setup/21 Frontend- Show categories depending on status/1.pptx
+++ b/.lessons/56 Category, Subcategory and Child Category Setup/21 Frontend- Show categories depending on status/1.pptx
@@ -6,8 +6,14 @@
   </p:sldMasterIdLst>
   <p:sldIdLst>
     <p:sldId id="413" r:id="rId2"/>
-    <p:sldId id="414" r:id="rId3"/>
-    <p:sldId id="400" r:id="rId4"/>
+    <p:sldId id="415" r:id="rId3"/>
+    <p:sldId id="416" r:id="rId4"/>
+    <p:sldId id="414" r:id="rId5"/>
+    <p:sldId id="417" r:id="rId6"/>
+    <p:sldId id="418" r:id="rId7"/>
+    <p:sldId id="419" r:id="rId8"/>
+    <p:sldId id="420" r:id="rId9"/>
+    <p:sldId id="400" r:id="rId10"/>
   </p:sldIdLst>
   <p:sldSz cx="12192000" cy="6858000"/>
   <p:notesSz cx="6858000" cy="9144000"/>
@@ -261,7 +267,7 @@
           <a:p>
             <a:fld id="{3E102D2E-813C-461C-9963-687A650C48C0}" type="datetimeFigureOut">
               <a:rPr lang="en-US" smtClean="0"/>
-              <a:t>6/26/2025</a:t>
+              <a:t>8/30/2025</a:t>
             </a:fld>
             <a:endParaRPr lang="en-US"/>
           </a:p>
@@ -459,7 +465,7 @@
           <a:p>
             <a:fld id="{3E102D2E-813C-461C-9963-687A650C48C0}" type="datetimeFigureOut">
               <a:rPr lang="en-US" smtClean="0"/>
-              <a:t>6/26/2025</a:t>
+              <a:t>8/30/2025</a:t>
             </a:fld>
             <a:endParaRPr lang="en-US"/>
           </a:p>
@@ -667,7 +673,7 @@
           <a:p>
             <a:fld id="{3E102D2E-813C-461C-9963-687A650C48C0}" type="datetimeFigureOut">
               <a:rPr lang="en-US" smtClean="0"/>
-              <a:t>6/26/2025</a:t>
+              <a:t>8/30/2025</a:t>
             </a:fld>
             <a:endParaRPr lang="en-US"/>
           </a:p>
@@ -865,7 +871,7 @@
           <a:p>
             <a:fld id="{3E102D2E-813C-461C-9963-687A650C48C0}" type="datetimeFigureOut">
               <a:rPr lang="en-US" smtClean="0"/>
-              <a:t>6/26/2025</a:t>
+              <a:t>8/30/2025</a:t>
             </a:fld>
             <a:endParaRPr lang="en-US"/>
           </a:p>
@@ -1140,7 +1146,7 @@
           <a:p>
             <a:fld id="{3E102D2E-813C-461C-9963-687A650C48C0}" type="datetimeFigureOut">
               <a:rPr lang="en-US" smtClean="0"/>
-              <a:t>6/26/2025</a:t>
+              <a:t>8/30/2025</a:t>
             </a:fld>
             <a:endParaRPr lang="en-US"/>
           </a:p>
@@ -1405,7 +1411,7 @@
           <a:p>
             <a:fld id="{3E102D2E-813C-461C-9963-687A650C48C0}" type="datetimeFigureOut">
               <a:rPr lang="en-US" smtClean="0"/>
-              <a:t>6/26/2025</a:t>
+              <a:t>8/30/2025</a:t>
             </a:fld>
             <a:endParaRPr lang="en-US"/>
           </a:p>
@@ -1817,7 +1823,7 @@
           <a:p>
             <a:fld id="{3E102D2E-813C-461C-9963-687A650C48C0}" type="datetimeFigureOut">
               <a:rPr lang="en-US" smtClean="0"/>
-              <a:t>6/26/2025</a:t>
+              <a:t>8/30/2025</a:t>
             </a:fld>
             <a:endParaRPr lang="en-US"/>
           </a:p>
@@ -1958,7 +1964,7 @@
           <a:p>
             <a:fld id="{3E102D2E-813C-461C-9963-687A650C48C0}" type="datetimeFigureOut">
               <a:rPr lang="en-US" smtClean="0"/>
-              <a:t>6/26/2025</a:t>
+              <a:t>8/30/2025</a:t>
             </a:fld>
             <a:endParaRPr lang="en-US"/>
           </a:p>
@@ -2071,7 +2077,7 @@
           <a:p>
             <a:fld id="{3E102D2E-813C-461C-9963-687A650C48C0}" type="datetimeFigureOut">
               <a:rPr lang="en-US" smtClean="0"/>
-              <a:t>6/26/2025</a:t>
+              <a:t>8/30/2025</a:t>
             </a:fld>
             <a:endParaRPr lang="en-US"/>
           </a:p>
@@ -2382,7 +2388,7 @@
           <a:p>
             <a:fld id="{3E102D2E-813C-461C-9963-687A650C48C0}" type="datetimeFigureOut">
               <a:rPr lang="en-US" smtClean="0"/>
-              <a:t>6/26/2025</a:t>
+              <a:t>8/30/2025</a:t>
             </a:fld>
             <a:endParaRPr lang="en-US"/>
           </a:p>
@@ -2670,7 +2676,7 @@
           <a:p>
             <a:fld id="{3E102D2E-813C-461C-9963-687A650C48C0}" type="datetimeFigureOut">
               <a:rPr lang="en-US" smtClean="0"/>
-              <a:t>6/26/2025</a:t>
+              <a:t>8/30/2025</a:t>
             </a:fld>
             <a:endParaRPr lang="en-US"/>
           </a:p>
@@ -2911,7 +2917,7 @@
           <a:p>
             <a:fld id="{3E102D2E-813C-461C-9963-687A650C48C0}" type="datetimeFigureOut">
               <a:rPr lang="en-US" smtClean="0"/>
-              <a:t>6/26/2025</a:t>
+              <a:t>8/30/2025</a:t>
             </a:fld>
             <a:endParaRPr lang="en-US"/>
           </a:p>
@@ -3349,7 +3355,7 @@
         <p:spPr>
           <a:xfrm>
             <a:off x="217714" y="255046"/>
-            <a:ext cx="11756571" cy="355354"/>
+            <a:ext cx="11756571" cy="1255600"/>
           </a:xfrm>
           <a:prstGeom prst="rect">
             <a:avLst/>
@@ -3369,21 +3375,130 @@
               <a:buNone/>
             </a:pPr>
             <a:r>
-              <a:rPr kumimoji="0" lang="en-US" altLang="en-US" sz="1300" b="0" i="0" u="none" strike="noStrike" cap="none" normalizeH="0" baseline="0">
-                <a:ln>
-                  <a:noFill/>
-                </a:ln>
-                <a:solidFill>
-                  <a:schemeClr val="tx1"/>
-                </a:solidFill>
-                <a:effectLst/>
+              <a:rPr lang="en-US" altLang="en-US" sz="1300" b="1">
                 <a:latin typeface="Arial" panose="020B0604020202020204" pitchFamily="34" charset="0"/>
               </a:rPr>
-              <a:t>.</a:t>
-            </a:r>
-          </a:p>
-        </p:txBody>
-      </p:sp>
+              <a:t>Status</a:t>
+            </a:r>
+            <a:r>
+              <a:rPr lang="en-US" altLang="en-US" sz="1300">
+                <a:latin typeface="Arial" panose="020B0604020202020204" pitchFamily="34" charset="0"/>
+              </a:rPr>
+              <a:t> -dan asılı olaraq kateqoriyaları göstərm</a:t>
+            </a:r>
+            <a:r>
+              <a:rPr lang="az-Latn-AZ" altLang="en-US" sz="1300">
+                <a:latin typeface="Arial" panose="020B0604020202020204" pitchFamily="34" charset="0"/>
+              </a:rPr>
+              <a:t>ək.</a:t>
+            </a:r>
+          </a:p>
+          <a:p>
+            <a:pPr>
+              <a:lnSpc>
+                <a:spcPct val="150000"/>
+              </a:lnSpc>
+              <a:buNone/>
+            </a:pPr>
+            <a:endParaRPr kumimoji="0" lang="az-Latn-AZ" altLang="en-US" sz="1300" b="0" i="0" u="none" strike="noStrike" cap="none" normalizeH="0" baseline="0">
+              <a:ln>
+                <a:noFill/>
+              </a:ln>
+              <a:solidFill>
+                <a:schemeClr val="tx1"/>
+              </a:solidFill>
+              <a:effectLst/>
+              <a:latin typeface="Arial" panose="020B0604020202020204" pitchFamily="34" charset="0"/>
+            </a:endParaRPr>
+          </a:p>
+          <a:p>
+            <a:pPr>
+              <a:lnSpc>
+                <a:spcPct val="150000"/>
+              </a:lnSpc>
+              <a:buNone/>
+            </a:pPr>
+            <a:r>
+              <a:rPr lang="en-US" altLang="en-US" sz="1300">
+                <a:latin typeface="Arial" panose="020B0604020202020204" pitchFamily="34" charset="0"/>
+              </a:rPr>
+              <a:t>Bunun </a:t>
+            </a:r>
+            <a:r>
+              <a:rPr lang="az-Latn-AZ" altLang="en-US" sz="1300">
+                <a:latin typeface="Arial" panose="020B0604020202020204" pitchFamily="34" charset="0"/>
+              </a:rPr>
+              <a:t>üçün </a:t>
+            </a:r>
+            <a:r>
+              <a:rPr lang="en-US" altLang="en-US" sz="1300" b="1">
+                <a:latin typeface="Arial" panose="020B0604020202020204" pitchFamily="34" charset="0"/>
+              </a:rPr>
+              <a:t>where() </a:t>
+            </a:r>
+            <a:r>
+              <a:rPr lang="en-US" altLang="en-US" sz="1300">
+                <a:latin typeface="Arial" panose="020B0604020202020204" pitchFamily="34" charset="0"/>
+              </a:rPr>
+              <a:t>metodu istifad</a:t>
+            </a:r>
+            <a:r>
+              <a:rPr lang="az-Latn-AZ" altLang="en-US" sz="1300">
+                <a:latin typeface="Arial" panose="020B0604020202020204" pitchFamily="34" charset="0"/>
+              </a:rPr>
+              <a:t>ə edirik.</a:t>
+            </a:r>
+          </a:p>
+          <a:p>
+            <a:pPr>
+              <a:lnSpc>
+                <a:spcPct val="150000"/>
+              </a:lnSpc>
+              <a:buNone/>
+            </a:pPr>
+            <a:endParaRPr kumimoji="0" lang="en-US" altLang="en-US" sz="1300" b="0" i="0" u="none" strike="noStrike" cap="none" normalizeH="0" baseline="0">
+              <a:ln>
+                <a:noFill/>
+              </a:ln>
+              <a:solidFill>
+                <a:schemeClr val="tx1"/>
+              </a:solidFill>
+              <a:effectLst/>
+              <a:latin typeface="Arial" panose="020B0604020202020204" pitchFamily="34" charset="0"/>
+            </a:endParaRPr>
+          </a:p>
+        </p:txBody>
+      </p:sp>
+      <p:pic>
+        <p:nvPicPr>
+          <p:cNvPr id="4" name="Picture 3">
+            <a:extLst>
+              <a:ext uri="{FF2B5EF4-FFF2-40B4-BE49-F238E27FC236}">
+                <a16:creationId xmlns:a16="http://schemas.microsoft.com/office/drawing/2014/main" id="{656C94F3-6157-9F0D-AE3D-39F00CCC793A}"/>
+              </a:ext>
+            </a:extLst>
+          </p:cNvPr>
+          <p:cNvPicPr>
+            <a:picLocks noChangeAspect="1"/>
+          </p:cNvPicPr>
+          <p:nvPr/>
+        </p:nvPicPr>
+        <p:blipFill>
+          <a:blip r:embed="rId2"/>
+          <a:stretch>
+            <a:fillRect/>
+          </a:stretch>
+        </p:blipFill>
+        <p:spPr>
+          <a:xfrm>
+            <a:off x="3484061" y="1339273"/>
+            <a:ext cx="8707939" cy="5518726"/>
+          </a:xfrm>
+          <a:prstGeom prst="rect">
+            <a:avLst/>
+          </a:prstGeom>
+        </p:spPr>
+      </p:pic>
     </p:spTree>
     <p:extLst>
       <p:ext uri="{BB962C8B-B14F-4D97-AF65-F5344CB8AC3E}">
@@ -3398,6 +3513,256 @@
 </file>
 
 <file path=ppt/slides/slide2.xml><?xml version="1.0" encoding="utf-8"?>
+<p:sld xmlns:a="http://schemas.openxmlformats.org/drawingml/2006/main" xmlns:r="http://schemas.openxmlformats.org/officeDocument/2006/relationships" xmlns:p="http://schemas.openxmlformats.org/presentationml/2006/main">
+  <p:cSld>
+    <p:spTree>
+      <p:nvGrpSpPr>
+        <p:cNvPr id="1" name="">
+          <a:extLst>
+            <a:ext uri="{FF2B5EF4-FFF2-40B4-BE49-F238E27FC236}">
+              <a16:creationId xmlns:a16="http://schemas.microsoft.com/office/drawing/2014/main" id="{675BE1CB-418C-4E42-37B9-280D1743C702}"/>
+            </a:ext>
+          </a:extLst>
+        </p:cNvPr>
+        <p:cNvGrpSpPr/>
+        <p:nvPr/>
+      </p:nvGrpSpPr>
+      <p:grpSpPr>
+        <a:xfrm>
+          <a:off x="0" y="0"/>
+          <a:ext cx="0" cy="0"/>
+          <a:chOff x="0" y="0"/>
+          <a:chExt cx="0" cy="0"/>
+        </a:xfrm>
+      </p:grpSpPr>
+      <p:sp>
+        <p:nvSpPr>
+          <p:cNvPr id="3" name="TextBox 2">
+            <a:extLst>
+              <a:ext uri="{FF2B5EF4-FFF2-40B4-BE49-F238E27FC236}">
+                <a16:creationId xmlns:a16="http://schemas.microsoft.com/office/drawing/2014/main" id="{E1B0F3F5-0F44-BE12-03DF-0532723E3A5D}"/>
+              </a:ext>
+            </a:extLst>
+          </p:cNvPr>
+          <p:cNvSpPr txBox="1"/>
+          <p:nvPr/>
+        </p:nvSpPr>
+        <p:spPr>
+          <a:xfrm>
+            <a:off x="217714" y="255046"/>
+            <a:ext cx="11756571" cy="355354"/>
+          </a:xfrm>
+          <a:prstGeom prst="rect">
+            <a:avLst/>
+          </a:prstGeom>
+          <a:noFill/>
+        </p:spPr>
+        <p:txBody>
+          <a:bodyPr wrap="square">
+            <a:spAutoFit/>
+          </a:bodyPr>
+          <a:lstStyle/>
+          <a:p>
+            <a:pPr>
+              <a:lnSpc>
+                <a:spcPct val="150000"/>
+              </a:lnSpc>
+              <a:buNone/>
+            </a:pPr>
+            <a:r>
+              <a:rPr lang="az-Latn-AZ" altLang="en-US" sz="1300">
+                <a:latin typeface="Arial" panose="020B0604020202020204" pitchFamily="34" charset="0"/>
+              </a:rPr>
+              <a:t>Fashion </a:t>
+            </a:r>
+            <a:r>
+              <a:rPr lang="az-Latn-AZ" altLang="en-US" sz="1300" b="1">
+                <a:latin typeface="Arial" panose="020B0604020202020204" pitchFamily="34" charset="0"/>
+              </a:rPr>
+              <a:t>Category</a:t>
+            </a:r>
+            <a:r>
+              <a:rPr lang="az-Latn-AZ" altLang="en-US" sz="1300">
+                <a:latin typeface="Arial" panose="020B0604020202020204" pitchFamily="34" charset="0"/>
+              </a:rPr>
+              <a:t> -sini söndürürük.</a:t>
+            </a:r>
+            <a:endParaRPr kumimoji="0" lang="en-US" altLang="en-US" sz="1300" b="0" i="0" u="none" strike="noStrike" cap="none" normalizeH="0" baseline="0">
+              <a:ln>
+                <a:noFill/>
+              </a:ln>
+              <a:solidFill>
+                <a:schemeClr val="tx1"/>
+              </a:solidFill>
+              <a:effectLst/>
+              <a:latin typeface="Arial" panose="020B0604020202020204" pitchFamily="34" charset="0"/>
+            </a:endParaRPr>
+          </a:p>
+        </p:txBody>
+      </p:sp>
+      <p:pic>
+        <p:nvPicPr>
+          <p:cNvPr id="4" name="Picture 3">
+            <a:extLst>
+              <a:ext uri="{FF2B5EF4-FFF2-40B4-BE49-F238E27FC236}">
+                <a16:creationId xmlns:a16="http://schemas.microsoft.com/office/drawing/2014/main" id="{F72C3694-3116-E119-F76A-C31796868DE1}"/>
+              </a:ext>
+            </a:extLst>
+          </p:cNvPr>
+          <p:cNvPicPr>
+            <a:picLocks noChangeAspect="1"/>
+          </p:cNvPicPr>
+          <p:nvPr/>
+        </p:nvPicPr>
+        <p:blipFill>
+          <a:blip r:embed="rId2"/>
+          <a:stretch>
+            <a:fillRect/>
+          </a:stretch>
+        </p:blipFill>
+        <p:spPr>
+          <a:xfrm>
+            <a:off x="0" y="2194671"/>
+            <a:ext cx="12192000" cy="4663329"/>
+          </a:xfrm>
+          <a:prstGeom prst="rect">
+            <a:avLst/>
+          </a:prstGeom>
+        </p:spPr>
+      </p:pic>
+    </p:spTree>
+    <p:extLst>
+      <p:ext uri="{BB962C8B-B14F-4D97-AF65-F5344CB8AC3E}">
+        <p14:creationId xmlns:p14="http://schemas.microsoft.com/office/powerpoint/2010/main" val="2866294458"/>
+      </p:ext>
+    </p:extLst>
+  </p:cSld>
+  <p:clrMapOvr>
+    <a:masterClrMapping/>
+  </p:clrMapOvr>
+</p:sld>
+</file>
+
+<file path=ppt/slides/slide3.xml><?xml version="1.0" encoding="utf-8"?>
+<p:sld xmlns:a="http://schemas.openxmlformats.org/drawingml/2006/main" xmlns:r="http://schemas.openxmlformats.org/officeDocument/2006/relationships" xmlns:p="http://schemas.openxmlformats.org/presentationml/2006/main">
+  <p:cSld>
+    <p:spTree>
+      <p:nvGrpSpPr>
+        <p:cNvPr id="1" name="">
+          <a:extLst>
+            <a:ext uri="{FF2B5EF4-FFF2-40B4-BE49-F238E27FC236}">
+              <a16:creationId xmlns:a16="http://schemas.microsoft.com/office/drawing/2014/main" id="{9CFD6735-66A9-7338-0A08-0C020DD7D4C1}"/>
+            </a:ext>
+          </a:extLst>
+        </p:cNvPr>
+        <p:cNvGrpSpPr/>
+        <p:nvPr/>
+      </p:nvGrpSpPr>
+      <p:grpSpPr>
+        <a:xfrm>
+          <a:off x="0" y="0"/>
+          <a:ext cx="0" cy="0"/>
+          <a:chOff x="0" y="0"/>
+          <a:chExt cx="0" cy="0"/>
+        </a:xfrm>
+      </p:grpSpPr>
+      <p:sp>
+        <p:nvSpPr>
+          <p:cNvPr id="3" name="TextBox 2">
+            <a:extLst>
+              <a:ext uri="{FF2B5EF4-FFF2-40B4-BE49-F238E27FC236}">
+                <a16:creationId xmlns:a16="http://schemas.microsoft.com/office/drawing/2014/main" id="{53FDC4FF-3868-EDBD-F6D9-AF5C44D4CFB9}"/>
+              </a:ext>
+            </a:extLst>
+          </p:cNvPr>
+          <p:cNvSpPr txBox="1"/>
+          <p:nvPr/>
+        </p:nvSpPr>
+        <p:spPr>
+          <a:xfrm>
+            <a:off x="217714" y="255046"/>
+            <a:ext cx="11756571" cy="355354"/>
+          </a:xfrm>
+          <a:prstGeom prst="rect">
+            <a:avLst/>
+          </a:prstGeom>
+          <a:noFill/>
+        </p:spPr>
+        <p:txBody>
+          <a:bodyPr wrap="square">
+            <a:spAutoFit/>
+          </a:bodyPr>
+          <a:lstStyle/>
+          <a:p>
+            <a:pPr>
+              <a:lnSpc>
+                <a:spcPct val="150000"/>
+              </a:lnSpc>
+              <a:buNone/>
+            </a:pPr>
+            <a:r>
+              <a:rPr lang="az-Latn-AZ" altLang="en-US" sz="1300">
+                <a:latin typeface="Arial" panose="020B0604020202020204" pitchFamily="34" charset="0"/>
+              </a:rPr>
+              <a:t>Fashion artıq tətbiqdə görünmür.</a:t>
+            </a:r>
+            <a:endParaRPr kumimoji="0" lang="en-US" altLang="en-US" sz="1300" b="0" i="0" u="none" strike="noStrike" cap="none" normalizeH="0" baseline="0">
+              <a:ln>
+                <a:noFill/>
+              </a:ln>
+              <a:solidFill>
+                <a:schemeClr val="tx1"/>
+              </a:solidFill>
+              <a:effectLst/>
+              <a:latin typeface="Arial" panose="020B0604020202020204" pitchFamily="34" charset="0"/>
+            </a:endParaRPr>
+          </a:p>
+        </p:txBody>
+      </p:sp>
+      <p:pic>
+        <p:nvPicPr>
+          <p:cNvPr id="4" name="Picture 3">
+            <a:extLst>
+              <a:ext uri="{FF2B5EF4-FFF2-40B4-BE49-F238E27FC236}">
+                <a16:creationId xmlns:a16="http://schemas.microsoft.com/office/drawing/2014/main" id="{FF2914E1-3259-C040-F264-1DA5342EDB6E}"/>
+              </a:ext>
+            </a:extLst>
+          </p:cNvPr>
+          <p:cNvPicPr>
+            <a:picLocks noChangeAspect="1"/>
+          </p:cNvPicPr>
+          <p:nvPr/>
+        </p:nvPicPr>
+        <p:blipFill>
+          <a:blip r:embed="rId2"/>
+          <a:stretch>
+            <a:fillRect/>
+          </a:stretch>
+        </p:blipFill>
+        <p:spPr>
+          <a:xfrm>
+            <a:off x="0" y="3429000"/>
+            <a:ext cx="12192000" cy="3397979"/>
+          </a:xfrm>
+          <a:prstGeom prst="rect">
+            <a:avLst/>
+          </a:prstGeom>
+        </p:spPr>
+      </p:pic>
+    </p:spTree>
+    <p:extLst>
+      <p:ext uri="{BB962C8B-B14F-4D97-AF65-F5344CB8AC3E}">
+        <p14:creationId xmlns:p14="http://schemas.microsoft.com/office/powerpoint/2010/main" val="4014429961"/>
+      </p:ext>
+    </p:extLst>
+  </p:cSld>
+  <p:clrMapOvr>
+    <a:masterClrMapping/>
+  </p:clrMapOvr>
+</p:sld>
+</file>
+
+<file path=ppt/slides/slide4.xml><?xml version="1.0" encoding="utf-8"?>
 <p:sld xmlns:a="http://schemas.openxmlformats.org/drawingml/2006/main" xmlns:r="http://schemas.openxmlformats.org/officeDocument/2006/relationships" xmlns:p="http://schemas.openxmlformats.org/presentationml/2006/main">
   <p:cSld>
     <p:spTree>
@@ -3435,7 +3800,7 @@
         <p:spPr>
           <a:xfrm>
             <a:off x="217714" y="255046"/>
-            <a:ext cx="11756571" cy="355354"/>
+            <a:ext cx="11756571" cy="955518"/>
           </a:xfrm>
           <a:prstGeom prst="rect">
             <a:avLst/>
@@ -3455,21 +3820,110 @@
               <a:buNone/>
             </a:pPr>
             <a:r>
-              <a:rPr kumimoji="0" lang="en-US" altLang="en-US" sz="1300" b="0" i="0" u="none" strike="noStrike" cap="none" normalizeH="0" baseline="0">
-                <a:ln>
-                  <a:noFill/>
-                </a:ln>
-                <a:solidFill>
-                  <a:schemeClr val="tx1"/>
-                </a:solidFill>
-                <a:effectLst/>
+              <a:rPr lang="az-Latn-AZ" altLang="en-US" sz="1300">
                 <a:latin typeface="Arial" panose="020B0604020202020204" pitchFamily="34" charset="0"/>
               </a:rPr>
-              <a:t>.</a:t>
-            </a:r>
-          </a:p>
-        </p:txBody>
-      </p:sp>
+              <a:t>Ancaq bu hələki </a:t>
+            </a:r>
+            <a:r>
+              <a:rPr lang="az-Latn-AZ" altLang="en-US" sz="1300" b="1">
+                <a:latin typeface="Arial" panose="020B0604020202020204" pitchFamily="34" charset="0"/>
+              </a:rPr>
+              <a:t>Child Category </a:t>
+            </a:r>
+            <a:r>
+              <a:rPr lang="az-Latn-AZ" altLang="en-US" sz="1300">
+                <a:latin typeface="Arial" panose="020B0604020202020204" pitchFamily="34" charset="0"/>
+              </a:rPr>
+              <a:t>-yə aid deyil.</a:t>
+            </a:r>
+          </a:p>
+          <a:p>
+            <a:pPr>
+              <a:lnSpc>
+                <a:spcPct val="150000"/>
+              </a:lnSpc>
+              <a:buNone/>
+            </a:pPr>
+            <a:endParaRPr kumimoji="0" lang="az-Latn-AZ" altLang="en-US" sz="1300" b="0" i="0" u="none" strike="noStrike" cap="none" normalizeH="0" baseline="0">
+              <a:ln>
+                <a:noFill/>
+              </a:ln>
+              <a:solidFill>
+                <a:schemeClr val="tx1"/>
+              </a:solidFill>
+              <a:effectLst/>
+              <a:latin typeface="Arial" panose="020B0604020202020204" pitchFamily="34" charset="0"/>
+            </a:endParaRPr>
+          </a:p>
+          <a:p>
+            <a:pPr>
+              <a:lnSpc>
+                <a:spcPct val="150000"/>
+              </a:lnSpc>
+              <a:buNone/>
+            </a:pPr>
+            <a:r>
+              <a:rPr lang="az-Latn-AZ" altLang="en-US" sz="1300">
+                <a:latin typeface="Arial" panose="020B0604020202020204" pitchFamily="34" charset="0"/>
+              </a:rPr>
+              <a:t>Məsələn, </a:t>
+            </a:r>
+            <a:r>
+              <a:rPr lang="az-Latn-AZ" altLang="en-US" sz="1300" b="1">
+                <a:latin typeface="Arial" panose="020B0604020202020204" pitchFamily="34" charset="0"/>
+              </a:rPr>
+              <a:t>Canon</a:t>
+            </a:r>
+            <a:r>
+              <a:rPr lang="az-Latn-AZ" altLang="en-US" sz="1300">
+                <a:latin typeface="Arial" panose="020B0604020202020204" pitchFamily="34" charset="0"/>
+              </a:rPr>
+              <a:t> sönülüdür.</a:t>
+            </a:r>
+            <a:endParaRPr kumimoji="0" lang="en-US" altLang="en-US" sz="1300" b="0" i="0" u="none" strike="noStrike" cap="none" normalizeH="0" baseline="0">
+              <a:ln>
+                <a:noFill/>
+              </a:ln>
+              <a:solidFill>
+                <a:schemeClr val="tx1"/>
+              </a:solidFill>
+              <a:effectLst/>
+              <a:latin typeface="Arial" panose="020B0604020202020204" pitchFamily="34" charset="0"/>
+            </a:endParaRPr>
+          </a:p>
+        </p:txBody>
+      </p:sp>
+      <p:pic>
+        <p:nvPicPr>
+          <p:cNvPr id="4" name="Picture 3">
+            <a:extLst>
+              <a:ext uri="{FF2B5EF4-FFF2-40B4-BE49-F238E27FC236}">
+                <a16:creationId xmlns:a16="http://schemas.microsoft.com/office/drawing/2014/main" id="{906DB2B8-A97F-599F-5810-AFDB192B91F0}"/>
+              </a:ext>
+            </a:extLst>
+          </p:cNvPr>
+          <p:cNvPicPr>
+            <a:picLocks noChangeAspect="1"/>
+          </p:cNvPicPr>
+          <p:nvPr/>
+        </p:nvPicPr>
+        <p:blipFill>
+          <a:blip r:embed="rId2"/>
+          <a:stretch>
+            <a:fillRect/>
+          </a:stretch>
+        </p:blipFill>
+        <p:spPr>
+          <a:xfrm>
+            <a:off x="0" y="2531397"/>
+            <a:ext cx="12192000" cy="4326603"/>
+          </a:xfrm>
+          <a:prstGeom prst="rect">
+            <a:avLst/>
+          </a:prstGeom>
+        </p:spPr>
+      </p:pic>
     </p:spTree>
     <p:extLst>
       <p:ext uri="{BB962C8B-B14F-4D97-AF65-F5344CB8AC3E}">
@@ -3483,7 +3937,674 @@
 </p:sld>
 </file>
 
-<file path=ppt/slides/slide3.xml><?xml version="1.0" encoding="utf-8"?>
+<file path=ppt/slides/slide5.xml><?xml version="1.0" encoding="utf-8"?>
+<p:sld xmlns:a="http://schemas.openxmlformats.org/drawingml/2006/main" xmlns:r="http://schemas.openxmlformats.org/officeDocument/2006/relationships" xmlns:p="http://schemas.openxmlformats.org/presentationml/2006/main">
+  <p:cSld>
+    <p:spTree>
+      <p:nvGrpSpPr>
+        <p:cNvPr id="1" name="">
+          <a:extLst>
+            <a:ext uri="{FF2B5EF4-FFF2-40B4-BE49-F238E27FC236}">
+              <a16:creationId xmlns:a16="http://schemas.microsoft.com/office/drawing/2014/main" id="{F9090F9F-4C04-E6E9-3991-CCD0C75ABAE0}"/>
+            </a:ext>
+          </a:extLst>
+        </p:cNvPr>
+        <p:cNvGrpSpPr/>
+        <p:nvPr/>
+      </p:nvGrpSpPr>
+      <p:grpSpPr>
+        <a:xfrm>
+          <a:off x="0" y="0"/>
+          <a:ext cx="0" cy="0"/>
+          <a:chOff x="0" y="0"/>
+          <a:chExt cx="0" cy="0"/>
+        </a:xfrm>
+      </p:grpSpPr>
+      <p:sp>
+        <p:nvSpPr>
+          <p:cNvPr id="3" name="TextBox 2">
+            <a:extLst>
+              <a:ext uri="{FF2B5EF4-FFF2-40B4-BE49-F238E27FC236}">
+                <a16:creationId xmlns:a16="http://schemas.microsoft.com/office/drawing/2014/main" id="{95CBF3E1-7A05-18E3-49DC-B46B1CD6514C}"/>
+              </a:ext>
+            </a:extLst>
+          </p:cNvPr>
+          <p:cNvSpPr txBox="1"/>
+          <p:nvPr/>
+        </p:nvSpPr>
+        <p:spPr>
+          <a:xfrm>
+            <a:off x="217714" y="255046"/>
+            <a:ext cx="11756571" cy="355354"/>
+          </a:xfrm>
+          <a:prstGeom prst="rect">
+            <a:avLst/>
+          </a:prstGeom>
+          <a:noFill/>
+        </p:spPr>
+        <p:txBody>
+          <a:bodyPr wrap="square">
+            <a:spAutoFit/>
+          </a:bodyPr>
+          <a:lstStyle/>
+          <a:p>
+            <a:pPr>
+              <a:lnSpc>
+                <a:spcPct val="150000"/>
+              </a:lnSpc>
+              <a:buNone/>
+            </a:pPr>
+            <a:r>
+              <a:rPr lang="az-Latn-AZ" altLang="en-US" sz="1300">
+                <a:latin typeface="Arial" panose="020B0604020202020204" pitchFamily="34" charset="0"/>
+              </a:rPr>
+              <a:t>Ancaq görünür.</a:t>
+            </a:r>
+            <a:endParaRPr kumimoji="0" lang="en-US" altLang="en-US" sz="1300" b="0" i="0" u="none" strike="noStrike" cap="none" normalizeH="0" baseline="0">
+              <a:ln>
+                <a:noFill/>
+              </a:ln>
+              <a:solidFill>
+                <a:schemeClr val="tx1"/>
+              </a:solidFill>
+              <a:effectLst/>
+              <a:latin typeface="Arial" panose="020B0604020202020204" pitchFamily="34" charset="0"/>
+            </a:endParaRPr>
+          </a:p>
+        </p:txBody>
+      </p:sp>
+      <p:pic>
+        <p:nvPicPr>
+          <p:cNvPr id="4" name="Picture 3">
+            <a:extLst>
+              <a:ext uri="{FF2B5EF4-FFF2-40B4-BE49-F238E27FC236}">
+                <a16:creationId xmlns:a16="http://schemas.microsoft.com/office/drawing/2014/main" id="{931F0BC2-3ACA-B57C-6146-9573D703B803}"/>
+              </a:ext>
+            </a:extLst>
+          </p:cNvPr>
+          <p:cNvPicPr>
+            <a:picLocks noChangeAspect="1"/>
+          </p:cNvPicPr>
+          <p:nvPr/>
+        </p:nvPicPr>
+        <p:blipFill>
+          <a:blip r:embed="rId2"/>
+          <a:stretch>
+            <a:fillRect/>
+          </a:stretch>
+        </p:blipFill>
+        <p:spPr>
+          <a:xfrm>
+            <a:off x="1455827" y="1904309"/>
+            <a:ext cx="10736173" cy="4953691"/>
+          </a:xfrm>
+          <a:prstGeom prst="rect">
+            <a:avLst/>
+          </a:prstGeom>
+        </p:spPr>
+      </p:pic>
+    </p:spTree>
+    <p:extLst>
+      <p:ext uri="{BB962C8B-B14F-4D97-AF65-F5344CB8AC3E}">
+        <p14:creationId xmlns:p14="http://schemas.microsoft.com/office/powerpoint/2010/main" val="3415948067"/>
+      </p:ext>
+    </p:extLst>
+  </p:cSld>
+  <p:clrMapOvr>
+    <a:masterClrMapping/>
+  </p:clrMapOvr>
+</p:sld>
+</file>
+
+<file path=ppt/slides/slide6.xml><?xml version="1.0" encoding="utf-8"?>
+<p:sld xmlns:a="http://schemas.openxmlformats.org/drawingml/2006/main" xmlns:r="http://schemas.openxmlformats.org/officeDocument/2006/relationships" xmlns:p="http://schemas.openxmlformats.org/presentationml/2006/main">
+  <p:cSld>
+    <p:spTree>
+      <p:nvGrpSpPr>
+        <p:cNvPr id="1" name="">
+          <a:extLst>
+            <a:ext uri="{FF2B5EF4-FFF2-40B4-BE49-F238E27FC236}">
+              <a16:creationId xmlns:a16="http://schemas.microsoft.com/office/drawing/2014/main" id="{3FC952AB-E1F2-D1B6-EF3F-DF5F83886374}"/>
+            </a:ext>
+          </a:extLst>
+        </p:cNvPr>
+        <p:cNvGrpSpPr/>
+        <p:nvPr/>
+      </p:nvGrpSpPr>
+      <p:grpSpPr>
+        <a:xfrm>
+          <a:off x="0" y="0"/>
+          <a:ext cx="0" cy="0"/>
+          <a:chOff x="0" y="0"/>
+          <a:chExt cx="0" cy="0"/>
+        </a:xfrm>
+      </p:grpSpPr>
+      <p:sp>
+        <p:nvSpPr>
+          <p:cNvPr id="3" name="TextBox 2">
+            <a:extLst>
+              <a:ext uri="{FF2B5EF4-FFF2-40B4-BE49-F238E27FC236}">
+                <a16:creationId xmlns:a16="http://schemas.microsoft.com/office/drawing/2014/main" id="{BF3F458F-AF9C-D1D1-DF4C-680DB19076EB}"/>
+              </a:ext>
+            </a:extLst>
+          </p:cNvPr>
+          <p:cNvSpPr txBox="1"/>
+          <p:nvPr/>
+        </p:nvSpPr>
+        <p:spPr>
+          <a:xfrm>
+            <a:off x="217714" y="255046"/>
+            <a:ext cx="11756571" cy="1255600"/>
+          </a:xfrm>
+          <a:prstGeom prst="rect">
+            <a:avLst/>
+          </a:prstGeom>
+          <a:noFill/>
+        </p:spPr>
+        <p:txBody>
+          <a:bodyPr wrap="square">
+            <a:spAutoFit/>
+          </a:bodyPr>
+          <a:lstStyle/>
+          <a:p>
+            <a:pPr>
+              <a:lnSpc>
+                <a:spcPct val="150000"/>
+              </a:lnSpc>
+              <a:buNone/>
+            </a:pPr>
+            <a:r>
+              <a:rPr lang="en-US" altLang="en-US" sz="1300">
+                <a:latin typeface="Arial" panose="020B0604020202020204" pitchFamily="34" charset="0"/>
+              </a:rPr>
+              <a:t>H</a:t>
+            </a:r>
+            <a:r>
+              <a:rPr lang="az-Latn-AZ" altLang="en-US" sz="1300">
+                <a:latin typeface="Arial" panose="020B0604020202020204" pitchFamily="34" charset="0"/>
+              </a:rPr>
+              <a:t>əm </a:t>
+            </a:r>
+            <a:r>
+              <a:rPr lang="az-Latn-AZ" altLang="en-US" sz="1300" b="1">
+                <a:latin typeface="Arial" panose="020B0604020202020204" pitchFamily="34" charset="0"/>
+              </a:rPr>
+              <a:t>SubCategory</a:t>
+            </a:r>
+            <a:r>
+              <a:rPr lang="az-Latn-AZ" altLang="en-US" sz="1300">
+                <a:latin typeface="Arial" panose="020B0604020202020204" pitchFamily="34" charset="0"/>
+              </a:rPr>
+              <a:t> həmdə </a:t>
+            </a:r>
+            <a:r>
+              <a:rPr lang="az-Latn-AZ" altLang="en-US" sz="1300" b="1">
+                <a:latin typeface="Arial" panose="020B0604020202020204" pitchFamily="34" charset="0"/>
+              </a:rPr>
+              <a:t>ChildCategory</a:t>
+            </a:r>
+            <a:r>
+              <a:rPr lang="az-Latn-AZ" altLang="en-US" sz="1300">
+                <a:latin typeface="Arial" panose="020B0604020202020204" pitchFamily="34" charset="0"/>
+              </a:rPr>
+              <a:t> üçün də, status əsaslı görünüm yaratmaq istəyiriksə onda, </a:t>
+            </a:r>
+            <a:r>
+              <a:rPr lang="en-US" altLang="en-US" sz="1300" b="1">
+                <a:latin typeface="Arial" panose="020B0604020202020204" pitchFamily="34" charset="0"/>
+              </a:rPr>
+              <a:t>with() </a:t>
+            </a:r>
+            <a:r>
+              <a:rPr lang="az-Latn-AZ" altLang="en-US" sz="1300">
+                <a:latin typeface="Arial" panose="020B0604020202020204" pitchFamily="34" charset="0"/>
+              </a:rPr>
+              <a:t>metodundan istifadə edə bilərik.</a:t>
+            </a:r>
+          </a:p>
+          <a:p>
+            <a:pPr>
+              <a:lnSpc>
+                <a:spcPct val="150000"/>
+              </a:lnSpc>
+              <a:buNone/>
+            </a:pPr>
+            <a:endParaRPr kumimoji="0" lang="az-Latn-AZ" altLang="en-US" sz="1300" b="0" i="0" u="none" strike="noStrike" cap="none" normalizeH="0" baseline="0">
+              <a:ln>
+                <a:noFill/>
+              </a:ln>
+              <a:solidFill>
+                <a:schemeClr val="tx1"/>
+              </a:solidFill>
+              <a:effectLst/>
+              <a:latin typeface="Arial" panose="020B0604020202020204" pitchFamily="34" charset="0"/>
+            </a:endParaRPr>
+          </a:p>
+          <a:p>
+            <a:pPr>
+              <a:lnSpc>
+                <a:spcPct val="150000"/>
+              </a:lnSpc>
+              <a:buNone/>
+            </a:pPr>
+            <a:r>
+              <a:rPr lang="az-Latn-AZ" altLang="en-US" sz="1300" b="1">
+                <a:solidFill>
+                  <a:schemeClr val="accent2"/>
+                </a:solidFill>
+                <a:latin typeface="Arial" panose="020B0604020202020204" pitchFamily="34" charset="0"/>
+              </a:rPr>
+              <a:t>NOT:</a:t>
+            </a:r>
+            <a:r>
+              <a:rPr lang="az-Latn-AZ" altLang="en-US" sz="1300">
+                <a:latin typeface="Arial" panose="020B0604020202020204" pitchFamily="34" charset="0"/>
+              </a:rPr>
+              <a:t> burada yazılan, </a:t>
+            </a:r>
+            <a:r>
+              <a:rPr lang="az-Latn-AZ" altLang="en-US" sz="1300" b="1">
+                <a:latin typeface="Arial" panose="020B0604020202020204" pitchFamily="34" charset="0"/>
+              </a:rPr>
+              <a:t>subCategories</a:t>
+            </a:r>
+            <a:r>
+              <a:rPr lang="az-Latn-AZ" altLang="en-US" sz="1300">
+                <a:latin typeface="Arial" panose="020B0604020202020204" pitchFamily="34" charset="0"/>
+              </a:rPr>
+              <a:t> və </a:t>
+            </a:r>
+            <a:r>
+              <a:rPr lang="az-Latn-AZ" altLang="en-US" sz="1300" b="1">
+                <a:latin typeface="Arial" panose="020B0604020202020204" pitchFamily="34" charset="0"/>
+              </a:rPr>
+              <a:t>childCategories</a:t>
+            </a:r>
+            <a:r>
+              <a:rPr lang="az-Latn-AZ" altLang="en-US" sz="1300">
+                <a:latin typeface="Arial" panose="020B0604020202020204" pitchFamily="34" charset="0"/>
+              </a:rPr>
+              <a:t> yazıları, </a:t>
+            </a:r>
+          </a:p>
+          <a:p>
+            <a:pPr>
+              <a:lnSpc>
+                <a:spcPct val="150000"/>
+              </a:lnSpc>
+              <a:buNone/>
+            </a:pPr>
+            <a:r>
+              <a:rPr kumimoji="0" lang="az-Latn-AZ" altLang="en-US" sz="1300" b="1" i="0" u="none" strike="noStrike" cap="none" normalizeH="0" baseline="0">
+                <a:ln>
+                  <a:noFill/>
+                </a:ln>
+                <a:solidFill>
+                  <a:schemeClr val="tx1"/>
+                </a:solidFill>
+                <a:effectLst/>
+                <a:latin typeface="Arial" panose="020B0604020202020204" pitchFamily="34" charset="0"/>
+              </a:rPr>
+              <a:t>model</a:t>
+            </a:r>
+            <a:r>
+              <a:rPr kumimoji="0" lang="az-Latn-AZ" altLang="en-US" sz="1300" b="0" i="0" u="none" strike="noStrike" cap="none" normalizeH="0" baseline="0">
+                <a:ln>
+                  <a:noFill/>
+                </a:ln>
+                <a:solidFill>
+                  <a:schemeClr val="tx1"/>
+                </a:solidFill>
+                <a:effectLst/>
+                <a:latin typeface="Arial" panose="020B0604020202020204" pitchFamily="34" charset="0"/>
+              </a:rPr>
+              <a:t> -in, </a:t>
+            </a:r>
+            <a:r>
+              <a:rPr kumimoji="0" lang="az-Latn-AZ" altLang="en-US" sz="1300" b="1" i="0" u="none" strike="noStrike" cap="none" normalizeH="0" baseline="0">
+                <a:ln>
+                  <a:noFill/>
+                </a:ln>
+                <a:solidFill>
+                  <a:schemeClr val="tx1"/>
+                </a:solidFill>
+                <a:effectLst/>
+                <a:latin typeface="Arial" panose="020B0604020202020204" pitchFamily="34" charset="0"/>
+              </a:rPr>
+              <a:t>relationship</a:t>
+            </a:r>
+            <a:r>
+              <a:rPr kumimoji="0" lang="az-Latn-AZ" altLang="en-US" sz="1300" b="0" i="0" u="none" strike="noStrike" cap="none" normalizeH="0" baseline="0">
+                <a:ln>
+                  <a:noFill/>
+                </a:ln>
+                <a:solidFill>
+                  <a:schemeClr val="tx1"/>
+                </a:solidFill>
+                <a:effectLst/>
+                <a:latin typeface="Arial" panose="020B0604020202020204" pitchFamily="34" charset="0"/>
+              </a:rPr>
+              <a:t> -ində istfiadə edil</a:t>
+            </a:r>
+            <a:r>
+              <a:rPr lang="az-Latn-AZ" altLang="en-US" sz="1300">
+                <a:latin typeface="Arial" panose="020B0604020202020204" pitchFamily="34" charset="0"/>
+              </a:rPr>
+              <a:t>ən funksiyaların adlarıdır.</a:t>
+            </a:r>
+            <a:endParaRPr kumimoji="0" lang="en-US" altLang="en-US" sz="1300" b="0" i="0" u="none" strike="noStrike" cap="none" normalizeH="0" baseline="0">
+              <a:ln>
+                <a:noFill/>
+              </a:ln>
+              <a:solidFill>
+                <a:schemeClr val="tx1"/>
+              </a:solidFill>
+              <a:effectLst/>
+              <a:latin typeface="Arial" panose="020B0604020202020204" pitchFamily="34" charset="0"/>
+            </a:endParaRPr>
+          </a:p>
+        </p:txBody>
+      </p:sp>
+      <p:pic>
+        <p:nvPicPr>
+          <p:cNvPr id="4" name="Picture 3">
+            <a:extLst>
+              <a:ext uri="{FF2B5EF4-FFF2-40B4-BE49-F238E27FC236}">
+                <a16:creationId xmlns:a16="http://schemas.microsoft.com/office/drawing/2014/main" id="{CCDB271B-6FD0-B765-5484-523EC6BD10E1}"/>
+              </a:ext>
+            </a:extLst>
+          </p:cNvPr>
+          <p:cNvPicPr>
+            <a:picLocks noChangeAspect="1"/>
+          </p:cNvPicPr>
+          <p:nvPr/>
+        </p:nvPicPr>
+        <p:blipFill>
+          <a:blip r:embed="rId2"/>
+          <a:stretch>
+            <a:fillRect/>
+          </a:stretch>
+        </p:blipFill>
+        <p:spPr>
+          <a:xfrm>
+            <a:off x="5980833" y="1189834"/>
+            <a:ext cx="6211167" cy="5668166"/>
+          </a:xfrm>
+          <a:prstGeom prst="rect">
+            <a:avLst/>
+          </a:prstGeom>
+        </p:spPr>
+      </p:pic>
+    </p:spTree>
+    <p:extLst>
+      <p:ext uri="{BB962C8B-B14F-4D97-AF65-F5344CB8AC3E}">
+        <p14:creationId xmlns:p14="http://schemas.microsoft.com/office/powerpoint/2010/main" val="2867916186"/>
+      </p:ext>
+    </p:extLst>
+  </p:cSld>
+  <p:clrMapOvr>
+    <a:masterClrMapping/>
+  </p:clrMapOvr>
+</p:sld>
+</file>
+
+<file path=ppt/slides/slide7.xml><?xml version="1.0" encoding="utf-8"?>
+<p:sld xmlns:a="http://schemas.openxmlformats.org/drawingml/2006/main" xmlns:r="http://schemas.openxmlformats.org/officeDocument/2006/relationships" xmlns:p="http://schemas.openxmlformats.org/presentationml/2006/main">
+  <p:cSld>
+    <p:spTree>
+      <p:nvGrpSpPr>
+        <p:cNvPr id="1" name="">
+          <a:extLst>
+            <a:ext uri="{FF2B5EF4-FFF2-40B4-BE49-F238E27FC236}">
+              <a16:creationId xmlns:a16="http://schemas.microsoft.com/office/drawing/2014/main" id="{754C9584-4EF3-E044-998F-382A6BE91846}"/>
+            </a:ext>
+          </a:extLst>
+        </p:cNvPr>
+        <p:cNvGrpSpPr/>
+        <p:nvPr/>
+      </p:nvGrpSpPr>
+      <p:grpSpPr>
+        <a:xfrm>
+          <a:off x="0" y="0"/>
+          <a:ext cx="0" cy="0"/>
+          <a:chOff x="0" y="0"/>
+          <a:chExt cx="0" cy="0"/>
+        </a:xfrm>
+      </p:grpSpPr>
+      <p:sp>
+        <p:nvSpPr>
+          <p:cNvPr id="3" name="TextBox 2">
+            <a:extLst>
+              <a:ext uri="{FF2B5EF4-FFF2-40B4-BE49-F238E27FC236}">
+                <a16:creationId xmlns:a16="http://schemas.microsoft.com/office/drawing/2014/main" id="{6B99E502-136E-71EC-9785-79C27628326E}"/>
+              </a:ext>
+            </a:extLst>
+          </p:cNvPr>
+          <p:cNvSpPr txBox="1"/>
+          <p:nvPr/>
+        </p:nvSpPr>
+        <p:spPr>
+          <a:xfrm>
+            <a:off x="217714" y="255046"/>
+            <a:ext cx="11756571" cy="355354"/>
+          </a:xfrm>
+          <a:prstGeom prst="rect">
+            <a:avLst/>
+          </a:prstGeom>
+          <a:noFill/>
+        </p:spPr>
+        <p:txBody>
+          <a:bodyPr wrap="square">
+            <a:spAutoFit/>
+          </a:bodyPr>
+          <a:lstStyle/>
+          <a:p>
+            <a:pPr>
+              <a:lnSpc>
+                <a:spcPct val="150000"/>
+              </a:lnSpc>
+              <a:buNone/>
+            </a:pPr>
+            <a:r>
+              <a:rPr kumimoji="0" lang="en-US" altLang="en-US" sz="1300" b="0" i="0" u="none" strike="noStrike" cap="none" normalizeH="0" baseline="0">
+                <a:ln>
+                  <a:noFill/>
+                </a:ln>
+                <a:solidFill>
+                  <a:schemeClr val="tx1"/>
+                </a:solidFill>
+                <a:effectLst/>
+                <a:latin typeface="Arial" panose="020B0604020202020204" pitchFamily="34" charset="0"/>
+              </a:rPr>
+              <a:t>.</a:t>
+            </a:r>
+          </a:p>
+        </p:txBody>
+      </p:sp>
+      <p:pic>
+        <p:nvPicPr>
+          <p:cNvPr id="6" name="Picture 5">
+            <a:extLst>
+              <a:ext uri="{FF2B5EF4-FFF2-40B4-BE49-F238E27FC236}">
+                <a16:creationId xmlns:a16="http://schemas.microsoft.com/office/drawing/2014/main" id="{EEEEE359-7451-4253-6A62-92AD04A6E397}"/>
+              </a:ext>
+            </a:extLst>
+          </p:cNvPr>
+          <p:cNvPicPr>
+            <a:picLocks noChangeAspect="1"/>
+          </p:cNvPicPr>
+          <p:nvPr/>
+        </p:nvPicPr>
+        <p:blipFill>
+          <a:blip r:embed="rId2"/>
+          <a:stretch>
+            <a:fillRect/>
+          </a:stretch>
+        </p:blipFill>
+        <p:spPr>
+          <a:xfrm>
+            <a:off x="0" y="1249353"/>
+            <a:ext cx="12192000" cy="4359293"/>
+          </a:xfrm>
+          <a:prstGeom prst="rect">
+            <a:avLst/>
+          </a:prstGeom>
+        </p:spPr>
+      </p:pic>
+    </p:spTree>
+    <p:extLst>
+      <p:ext uri="{BB962C8B-B14F-4D97-AF65-F5344CB8AC3E}">
+        <p14:creationId xmlns:p14="http://schemas.microsoft.com/office/powerpoint/2010/main" val="3023332678"/>
+      </p:ext>
+    </p:extLst>
+  </p:cSld>
+  <p:clrMapOvr>
+    <a:masterClrMapping/>
+  </p:clrMapOvr>
+</p:sld>
+</file>
+
+<file path=ppt/slides/slide8.xml><?xml version="1.0" encoding="utf-8"?>
+<p:sld xmlns:a="http://schemas.openxmlformats.org/drawingml/2006/main" xmlns:r="http://schemas.openxmlformats.org/officeDocument/2006/relationships" xmlns:p="http://schemas.openxmlformats.org/presentationml/2006/main">
+  <p:cSld>
+    <p:spTree>
+      <p:nvGrpSpPr>
+        <p:cNvPr id="1" name="">
+          <a:extLst>
+            <a:ext uri="{FF2B5EF4-FFF2-40B4-BE49-F238E27FC236}">
+              <a16:creationId xmlns:a16="http://schemas.microsoft.com/office/drawing/2014/main" id="{039701ED-FD8B-6963-C2E3-AD10ABBB767B}"/>
+            </a:ext>
+          </a:extLst>
+        </p:cNvPr>
+        <p:cNvGrpSpPr/>
+        <p:nvPr/>
+      </p:nvGrpSpPr>
+      <p:grpSpPr>
+        <a:xfrm>
+          <a:off x="0" y="0"/>
+          <a:ext cx="0" cy="0"/>
+          <a:chOff x="0" y="0"/>
+          <a:chExt cx="0" cy="0"/>
+        </a:xfrm>
+      </p:grpSpPr>
+      <p:sp>
+        <p:nvSpPr>
+          <p:cNvPr id="3" name="TextBox 2">
+            <a:extLst>
+              <a:ext uri="{FF2B5EF4-FFF2-40B4-BE49-F238E27FC236}">
+                <a16:creationId xmlns:a16="http://schemas.microsoft.com/office/drawing/2014/main" id="{6646B81A-14FD-BE87-0B06-8EE409D9C287}"/>
+              </a:ext>
+            </a:extLst>
+          </p:cNvPr>
+          <p:cNvSpPr txBox="1"/>
+          <p:nvPr/>
+        </p:nvSpPr>
+        <p:spPr>
+          <a:xfrm>
+            <a:off x="217714" y="255046"/>
+            <a:ext cx="11756571" cy="355354"/>
+          </a:xfrm>
+          <a:prstGeom prst="rect">
+            <a:avLst/>
+          </a:prstGeom>
+          <a:noFill/>
+        </p:spPr>
+        <p:txBody>
+          <a:bodyPr wrap="square">
+            <a:spAutoFit/>
+          </a:bodyPr>
+          <a:lstStyle/>
+          <a:p>
+            <a:pPr>
+              <a:lnSpc>
+                <a:spcPct val="150000"/>
+              </a:lnSpc>
+              <a:buNone/>
+            </a:pPr>
+            <a:r>
+              <a:rPr kumimoji="0" lang="az-Latn-AZ" altLang="en-US" sz="1300" b="0" i="0" u="none" strike="noStrike" cap="none" normalizeH="0" baseline="0">
+                <a:ln>
+                  <a:noFill/>
+                </a:ln>
+                <a:solidFill>
+                  <a:schemeClr val="tx1"/>
+                </a:solidFill>
+                <a:effectLst/>
+                <a:latin typeface="Arial" panose="020B0604020202020204" pitchFamily="34" charset="0"/>
+              </a:rPr>
+              <a:t>Nəticə.</a:t>
+            </a:r>
+            <a:endParaRPr kumimoji="0" lang="en-US" altLang="en-US" sz="1300" b="0" i="0" u="none" strike="noStrike" cap="none" normalizeH="0" baseline="0">
+              <a:ln>
+                <a:noFill/>
+              </a:ln>
+              <a:solidFill>
+                <a:schemeClr val="tx1"/>
+              </a:solidFill>
+              <a:effectLst/>
+              <a:latin typeface="Arial" panose="020B0604020202020204" pitchFamily="34" charset="0"/>
+            </a:endParaRPr>
+          </a:p>
+        </p:txBody>
+      </p:sp>
+      <p:pic>
+        <p:nvPicPr>
+          <p:cNvPr id="4" name="Picture 3">
+            <a:extLst>
+              <a:ext uri="{FF2B5EF4-FFF2-40B4-BE49-F238E27FC236}">
+                <a16:creationId xmlns:a16="http://schemas.microsoft.com/office/drawing/2014/main" id="{D0135D75-F30D-EBBB-35F1-FD61D9DE58C3}"/>
+              </a:ext>
+            </a:extLst>
+          </p:cNvPr>
+          <p:cNvPicPr>
+            <a:picLocks noChangeAspect="1"/>
+          </p:cNvPicPr>
+          <p:nvPr/>
+        </p:nvPicPr>
+        <p:blipFill>
+          <a:blip r:embed="rId2"/>
+          <a:stretch>
+            <a:fillRect/>
+          </a:stretch>
+        </p:blipFill>
+        <p:spPr>
+          <a:xfrm>
+            <a:off x="2779987" y="1237466"/>
+            <a:ext cx="9412013" cy="5620534"/>
+          </a:xfrm>
+          <a:prstGeom prst="rect">
+            <a:avLst/>
+          </a:prstGeom>
+          <a:ln w="38100" cap="sq">
+            <a:solidFill>
+              <a:srgbClr val="000000"/>
+            </a:solidFill>
+            <a:prstDash val="solid"/>
+            <a:miter lim="800000"/>
+          </a:ln>
+          <a:effectLst>
+            <a:outerShdw blurRad="50800" dist="38100" dir="2700000" algn="tl" rotWithShape="0">
+              <a:srgbClr val="000000">
+                <a:alpha val="43000"/>
+              </a:srgbClr>
+            </a:outerShdw>
+          </a:effectLst>
+        </p:spPr>
+      </p:pic>
+    </p:spTree>
+    <p:extLst>
+      <p:ext uri="{BB962C8B-B14F-4D97-AF65-F5344CB8AC3E}">
+        <p14:creationId xmlns:p14="http://schemas.microsoft.com/office/powerpoint/2010/main" val="3562311334"/>
+      </p:ext>
+    </p:extLst>
+  </p:cSld>
+  <p:clrMapOvr>
+    <a:masterClrMapping/>
+  </p:clrMapOvr>
+</p:sld>
+</file>
+
+<file path=ppt/slides/slide9.xml><?xml version="1.0" encoding="utf-8"?>
 <p:sld xmlns:a="http://schemas.openxmlformats.org/drawingml/2006/main" xmlns:r="http://schemas.openxmlformats.org/officeDocument/2006/relationships" xmlns:p="http://schemas.openxmlformats.org/presentationml/2006/main">
   <p:cSld>
     <p:spTree>

</xml_diff>